<commit_message>
updated docs assets and presentation
</commit_message>
<xml_diff>
--- a/src/main/docs/assets/tentackle-ai-agents.pptx
+++ b/src/main/docs/assets/tentackle-ai-agents.pptx
@@ -3153,7 +3153,7 @@
                 </a:solidFill>
                 <a:latin typeface="Segoe UI"/>
               </a:rPr>
-              <a:t>What a coding agent can drive — one live model server, five headless Maven goals.</a:t>
+              <a:t>What a coding agent can drive — one live model server, six headless Maven goals.</a:t>
             </a:r>
           </a:p>
         </p:txBody>
@@ -3210,8 +3210,8 @@
         </p:nvSpPr>
         <p:spPr>
           <a:xfrm>
-            <a:off x="566928" y="1517904"/>
-            <a:ext cx="2084831" cy="4169664"/>
+            <a:off x="566928" y="1470000"/>
+            <a:ext cx="2084831" cy="4289000"/>
           </a:xfrm>
           <a:prstGeom prst="roundRect">
             <a:avLst>
@@ -3316,7 +3316,7 @@
         </p:nvSpPr>
         <p:spPr>
           <a:xfrm>
-            <a:off x="2743199" y="1741932"/>
+            <a:off x="2743199" y="1664776"/>
             <a:ext cx="475488" cy="155448"/>
           </a:xfrm>
           <a:prstGeom prst="rightArrow">
@@ -3360,8 +3360,8 @@
         </p:nvSpPr>
         <p:spPr>
           <a:xfrm>
-            <a:off x="3310128" y="1517904"/>
-            <a:ext cx="2788920" cy="603504"/>
+            <a:off x="3310128" y="1470000"/>
+            <a:ext cx="2788920" cy="545000"/>
           </a:xfrm>
           <a:prstGeom prst="roundRect">
             <a:avLst>
@@ -3398,7 +3398,7 @@
           <a:p>
             <a:pPr algn="l"/>
             <a:r>
-              <a:rPr sz="1300" b="1">
+              <a:rPr sz="1200" b="1">
                 <a:solidFill>
                   <a:srgbClr val="1C252E"/>
                 </a:solidFill>
@@ -3429,8 +3429,8 @@
         </p:nvSpPr>
         <p:spPr>
           <a:xfrm>
-            <a:off x="6446520" y="1517904"/>
-            <a:ext cx="5193792" cy="603504"/>
+            <a:off x="6446520" y="1470000"/>
+            <a:ext cx="5193792" cy="545000"/>
           </a:xfrm>
           <a:prstGeom prst="rect">
             <a:avLst/>
@@ -3464,7 +3464,7 @@
         </p:nvSpPr>
         <p:spPr>
           <a:xfrm>
-            <a:off x="3310128" y="2169922"/>
+            <a:off x="3310128" y="2054500"/>
             <a:ext cx="8330184" cy="12700"/>
           </a:xfrm>
           <a:prstGeom prst="rect">
@@ -3508,7 +3508,7 @@
         </p:nvSpPr>
         <p:spPr>
           <a:xfrm>
-            <a:off x="2743199" y="2455164"/>
+            <a:off x="2743199" y="2288776"/>
             <a:ext cx="475488" cy="155448"/>
           </a:xfrm>
           <a:prstGeom prst="rightArrow">
@@ -3552,8 +3552,8 @@
         </p:nvSpPr>
         <p:spPr>
           <a:xfrm>
-            <a:off x="3310128" y="2231136"/>
-            <a:ext cx="2788920" cy="603504"/>
+            <a:off x="3310128" y="2094000"/>
+            <a:ext cx="2788920" cy="545000"/>
           </a:xfrm>
           <a:prstGeom prst="roundRect">
             <a:avLst>
@@ -3590,7 +3590,7 @@
           <a:p>
             <a:pPr algn="l"/>
             <a:r>
-              <a:rPr sz="1300" b="1">
+              <a:rPr sz="1200" b="1">
                 <a:solidFill>
                   <a:srgbClr val="1C252E"/>
                 </a:solidFill>
@@ -3621,8 +3621,8 @@
         </p:nvSpPr>
         <p:spPr>
           <a:xfrm>
-            <a:off x="6446520" y="2231136"/>
-            <a:ext cx="5193792" cy="603504"/>
+            <a:off x="6446520" y="2094000"/>
+            <a:ext cx="5193792" cy="545000"/>
           </a:xfrm>
           <a:prstGeom prst="rect">
             <a:avLst/>
@@ -3650,13 +3650,13 @@
       </p:sp>
       <p:sp>
         <p:nvSpPr>
-          <p:cNvPr id="13" name="Right Arrow 12"/>
+          <p:cNvPr id="35" name="Right Arrow 35"/>
           <p:cNvSpPr/>
           <p:nvPr/>
         </p:nvSpPr>
         <p:spPr>
           <a:xfrm>
-            <a:off x="2743199" y="3168396"/>
+            <a:off x="2743199" y="2912776"/>
             <a:ext cx="475488" cy="155448"/>
           </a:xfrm>
           <a:prstGeom prst="rightArrow">
@@ -3694,14 +3694,14 @@
       </p:sp>
       <p:sp>
         <p:nvSpPr>
-          <p:cNvPr id="14" name="Rounded Rectangle 13"/>
+          <p:cNvPr id="33" name="Rounded Rectangle 33"/>
           <p:cNvSpPr/>
           <p:nvPr/>
         </p:nvSpPr>
         <p:spPr>
           <a:xfrm>
-            <a:off x="3310128" y="2944368"/>
-            <a:ext cx="2788920" cy="603504"/>
+            <a:off x="3310128" y="2718000"/>
+            <a:ext cx="2788920" cy="545000"/>
           </a:xfrm>
           <a:prstGeom prst="roundRect">
             <a:avLst>
@@ -3738,13 +3738,13 @@
           <a:p>
             <a:pPr algn="l"/>
             <a:r>
-              <a:rPr sz="1300" b="1">
+              <a:rPr sz="1200" b="1">
                 <a:solidFill>
                   <a:srgbClr val="1C252E"/>
                 </a:solidFill>
                 <a:latin typeface="Consolas"/>
               </a:rPr>
-              <a:t>tentackle-wizard:browse</a:t>
+              <a:t>tentackle-wizard:operation</a:t>
             </a:r>
           </a:p>
           <a:p>
@@ -3756,21 +3756,21 @@
                 </a:solidFill>
                 <a:latin typeface="Consolas"/>
               </a:rPr>
-              <a:t>-Dpdo=… -Doutput=…</a:t>
-            </a:r>
-          </a:p>
-        </p:txBody>
-      </p:sp>
-      <p:sp>
-        <p:nvSpPr>
-          <p:cNvPr id="15" name="TextBox 14"/>
+              <a:t>-DoperationName=…</a:t>
+            </a:r>
+          </a:p>
+        </p:txBody>
+      </p:sp>
+      <p:sp>
+        <p:nvSpPr>
+          <p:cNvPr id="34" name="TextBox 34"/>
           <p:cNvSpPr txBox="1"/>
           <p:nvPr/>
         </p:nvSpPr>
         <p:spPr>
           <a:xfrm>
-            <a:off x="6446520" y="2944368"/>
-            <a:ext cx="5193792" cy="603504"/>
+            <a:off x="6446520" y="2718000"/>
+            <a:ext cx="5193792" cy="545000"/>
           </a:xfrm>
           <a:prstGeom prst="rect">
             <a:avLst/>
@@ -3791,6 +3791,154 @@
                 </a:solidFill>
                 <a:latin typeface="Segoe UI"/>
               </a:rPr>
+              <a:t>Writes the source files of a new operation — behavior without an entity</a:t>
+            </a:r>
+          </a:p>
+        </p:txBody>
+      </p:sp>
+      <p:sp>
+        <p:nvSpPr>
+          <p:cNvPr id="13" name="Right Arrow 12"/>
+          <p:cNvSpPr/>
+          <p:nvPr/>
+        </p:nvSpPr>
+        <p:spPr>
+          <a:xfrm>
+            <a:off x="2743199" y="3536776"/>
+            <a:ext cx="475488" cy="155448"/>
+          </a:xfrm>
+          <a:prstGeom prst="rightArrow">
+            <a:avLst/>
+          </a:prstGeom>
+          <a:solidFill>
+            <a:srgbClr val="B1771D"/>
+          </a:solidFill>
+          <a:ln>
+            <a:noFill/>
+          </a:ln>
+          <a:effectLst/>
+        </p:spPr>
+        <p:style>
+          <a:lnRef idx="1">
+            <a:schemeClr val="accent1"/>
+          </a:lnRef>
+          <a:fillRef idx="3">
+            <a:schemeClr val="accent1"/>
+          </a:fillRef>
+          <a:effectRef idx="2">
+            <a:schemeClr val="accent1"/>
+          </a:effectRef>
+          <a:fontRef idx="minor">
+            <a:schemeClr val="lt1"/>
+          </a:fontRef>
+        </p:style>
+        <p:txBody>
+          <a:bodyPr rtlCol="0" anchor="ctr"/>
+          <a:lstStyle/>
+          <a:p>
+            <a:pPr algn="ctr"/>
+          </a:p>
+        </p:txBody>
+      </p:sp>
+      <p:sp>
+        <p:nvSpPr>
+          <p:cNvPr id="14" name="Rounded Rectangle 13"/>
+          <p:cNvSpPr/>
+          <p:nvPr/>
+        </p:nvSpPr>
+        <p:spPr>
+          <a:xfrm>
+            <a:off x="3310128" y="3342000"/>
+            <a:ext cx="2788920" cy="545000"/>
+          </a:xfrm>
+          <a:prstGeom prst="roundRect">
+            <a:avLst>
+              <a:gd name="adj" fmla="val 16000"/>
+            </a:avLst>
+          </a:prstGeom>
+          <a:solidFill>
+            <a:srgbClr val="FBF2E0"/>
+          </a:solidFill>
+          <a:ln w="13970">
+            <a:solidFill>
+              <a:srgbClr val="B1771D"/>
+            </a:solidFill>
+          </a:ln>
+          <a:effectLst/>
+        </p:spPr>
+        <p:style>
+          <a:lnRef idx="1">
+            <a:schemeClr val="accent1"/>
+          </a:lnRef>
+          <a:fillRef idx="3">
+            <a:schemeClr val="accent1"/>
+          </a:fillRef>
+          <a:effectRef idx="2">
+            <a:schemeClr val="accent1"/>
+          </a:effectRef>
+          <a:fontRef idx="minor">
+            <a:schemeClr val="lt1"/>
+          </a:fontRef>
+        </p:style>
+        <p:txBody>
+          <a:bodyPr rtlCol="0" anchor="ctr" wrap="square" lIns="128016"/>
+          <a:lstStyle/>
+          <a:p>
+            <a:pPr algn="l"/>
+            <a:r>
+              <a:rPr sz="1200" b="1">
+                <a:solidFill>
+                  <a:srgbClr val="1C252E"/>
+                </a:solidFill>
+                <a:latin typeface="Consolas"/>
+              </a:rPr>
+              <a:t>tentackle-wizard:browse</a:t>
+            </a:r>
+          </a:p>
+          <a:p>
+            <a:pPr algn="l"/>
+            <a:r>
+              <a:rPr sz="950">
+                <a:solidFill>
+                  <a:srgbClr val="6B7684"/>
+                </a:solidFill>
+                <a:latin typeface="Consolas"/>
+              </a:rPr>
+              <a:t>-Dpdo=… -Doutput=…</a:t>
+            </a:r>
+          </a:p>
+        </p:txBody>
+      </p:sp>
+      <p:sp>
+        <p:nvSpPr>
+          <p:cNvPr id="15" name="TextBox 14"/>
+          <p:cNvSpPr txBox="1"/>
+          <p:nvPr/>
+        </p:nvSpPr>
+        <p:spPr>
+          <a:xfrm>
+            <a:off x="6446520" y="3342000"/>
+            <a:ext cx="5193792" cy="545000"/>
+          </a:xfrm>
+          <a:prstGeom prst="rect">
+            <a:avLst/>
+          </a:prstGeom>
+          <a:noFill/>
+        </p:spPr>
+        <p:txBody>
+          <a:bodyPr wrap="square" lIns="0" rIns="0" tIns="0" bIns="0" anchor="ctr">
+            <a:spAutoFit/>
+          </a:bodyPr>
+          <a:lstStyle/>
+          <a:p>
+            <a:pPr algn="l"/>
+            <a:r>
+              <a:rPr sz="1200" b="0" i="0">
+                <a:solidFill>
+                  <a:srgbClr val="1C252E"/>
+                </a:solidFill>
+                <a:latin typeface="Segoe UI"/>
+              </a:rPr>
               <a:t>Reads persisted objects → Java test fixtures</a:t>
             </a:r>
           </a:p>
@@ -3804,7 +3952,7 @@
         </p:nvSpPr>
         <p:spPr>
           <a:xfrm>
-            <a:off x="2743199" y="3881628"/>
+            <a:off x="2743199" y="4160776"/>
             <a:ext cx="475488" cy="155448"/>
           </a:xfrm>
           <a:prstGeom prst="rightArrow">
@@ -3848,8 +3996,8 @@
         </p:nvSpPr>
         <p:spPr>
           <a:xfrm>
-            <a:off x="3310128" y="3657600"/>
-            <a:ext cx="2788920" cy="603504"/>
+            <a:off x="3310128" y="3966000"/>
+            <a:ext cx="2788920" cy="545000"/>
           </a:xfrm>
           <a:prstGeom prst="roundRect">
             <a:avLst>
@@ -3886,7 +4034,7 @@
           <a:p>
             <a:pPr algn="l"/>
             <a:r>
-              <a:rPr sz="1300" b="1">
+              <a:rPr sz="1200" b="1">
                 <a:solidFill>
                   <a:srgbClr val="1C252E"/>
                 </a:solidFill>
@@ -3917,8 +4065,8 @@
         </p:nvSpPr>
         <p:spPr>
           <a:xfrm>
-            <a:off x="6446520" y="3657600"/>
-            <a:ext cx="5193792" cy="603504"/>
+            <a:off x="6446520" y="3966000"/>
+            <a:ext cx="5193792" cy="545000"/>
           </a:xfrm>
           <a:prstGeom prst="rect">
             <a:avLst/>
@@ -3952,7 +4100,7 @@
         </p:nvSpPr>
         <p:spPr>
           <a:xfrm>
-            <a:off x="2743199" y="4594860"/>
+            <a:off x="2743199" y="4784776"/>
             <a:ext cx="475488" cy="155448"/>
           </a:xfrm>
           <a:prstGeom prst="rightArrow">
@@ -3996,8 +4144,8 @@
         </p:nvSpPr>
         <p:spPr>
           <a:xfrm>
-            <a:off x="3310128" y="4370832"/>
-            <a:ext cx="2788920" cy="603504"/>
+            <a:off x="3310128" y="4590000"/>
+            <a:ext cx="2788920" cy="545000"/>
           </a:xfrm>
           <a:prstGeom prst="roundRect">
             <a:avLst>
@@ -4034,7 +4182,7 @@
           <a:p>
             <a:pPr algn="l"/>
             <a:r>
-              <a:rPr sz="1300" b="1">
+              <a:rPr sz="1200" b="1">
                 <a:solidFill>
                   <a:srgbClr val="1C252E"/>
                 </a:solidFill>
@@ -4065,8 +4213,8 @@
         </p:nvSpPr>
         <p:spPr>
           <a:xfrm>
-            <a:off x="6446520" y="4370832"/>
-            <a:ext cx="5193792" cy="603504"/>
+            <a:off x="6446520" y="4590000"/>
+            <a:ext cx="5193792" cy="545000"/>
           </a:xfrm>
           <a:prstGeom prst="rect">
             <a:avLst/>
@@ -4100,7 +4248,7 @@
         </p:nvSpPr>
         <p:spPr>
           <a:xfrm>
-            <a:off x="2743199" y="5308092"/>
+            <a:off x="2743199" y="5408776"/>
             <a:ext cx="475488" cy="155448"/>
           </a:xfrm>
           <a:prstGeom prst="rightArrow">
@@ -4144,8 +4292,8 @@
         </p:nvSpPr>
         <p:spPr>
           <a:xfrm>
-            <a:off x="3310128" y="5084064"/>
-            <a:ext cx="2788920" cy="603504"/>
+            <a:off x="3310128" y="5214000"/>
+            <a:ext cx="2788920" cy="545000"/>
           </a:xfrm>
           <a:prstGeom prst="roundRect">
             <a:avLst>
@@ -4182,7 +4330,7 @@
           <a:p>
             <a:pPr algn="l"/>
             <a:r>
-              <a:rPr sz="1300" b="1">
+              <a:rPr sz="1200" b="1">
                 <a:solidFill>
                   <a:srgbClr val="1C252E"/>
                 </a:solidFill>
@@ -4213,8 +4361,8 @@
         </p:nvSpPr>
         <p:spPr>
           <a:xfrm>
-            <a:off x="6446520" y="5084064"/>
-            <a:ext cx="5193792" cy="603504"/>
+            <a:off x="6446520" y="5214000"/>
+            <a:ext cx="5193792" cy="545000"/>
           </a:xfrm>
           <a:prstGeom prst="rect">
             <a:avLst/>

</xml_diff>